<commit_message>
2/3 mio update / tab_senko.tex追加
</commit_message>
<xml_diff>
--- a/fig/pawapo.pptx
+++ b/fig/pawapo.pptx
@@ -6,6 +6,7 @@
   </p:sldMasterIdLst>
   <p:sldIdLst>
     <p:sldId id="257" r:id="rId2"/>
+    <p:sldId id="258" r:id="rId3"/>
   </p:sldIdLst>
   <p:sldSz cx="12192000" cy="6858000"/>
   <p:notesSz cx="6858000" cy="9144000"/>
@@ -104,7 +105,224 @@
       </a:defRPr>
     </a:lvl9pPr>
   </p:defaultTextStyle>
+  <p:extLst>
+    <p:ext uri="{EFAFB233-063F-42B5-8137-9DF3F51BA10A}">
+      <p15:sldGuideLst xmlns:p15="http://schemas.microsoft.com/office/powerpoint/2012/main"/>
+    </p:ext>
+  </p:extLst>
 </p:presentation>
+</file>
+
+<file path=ppt/revisionInfo.xml><?xml version="1.0" encoding="utf-8"?>
+<p1510:revInfo xmlns:a="http://schemas.openxmlformats.org/drawingml/2006/main" xmlns:r="http://schemas.openxmlformats.org/officeDocument/2006/relationships" xmlns:p1510="http://schemas.microsoft.com/office/powerpoint/2015/10/main">
+  <p1510:revLst>
+    <p1510:client id="{14D7E5BE-DE1B-417A-B5B0-45924947C239}" v="3" dt="2025-01-30T05:49:30.505"/>
+  </p1510:revLst>
+</p1510:revInfo>
+</file>
+
+<file path=ppt/changesInfos/changesInfo1.xml><?xml version="1.0" encoding="utf-8"?>
+<pc:chgInfo xmlns:a="http://schemas.openxmlformats.org/drawingml/2006/main" xmlns:r="http://schemas.openxmlformats.org/officeDocument/2006/relationships" xmlns:ac="http://schemas.microsoft.com/office/drawing/2013/main/command" xmlns:pc="http://schemas.microsoft.com/office/powerpoint/2013/main/command">
+  <pc:docChgLst>
+    <pc:chgData name="mio sasaki" userId="4a654686f18dab2c" providerId="LiveId" clId="{14D7E5BE-DE1B-417A-B5B0-45924947C239}"/>
+    <pc:docChg chg="custSel addSld modSld">
+      <pc:chgData name="mio sasaki" userId="4a654686f18dab2c" providerId="LiveId" clId="{14D7E5BE-DE1B-417A-B5B0-45924947C239}" dt="2025-01-30T18:04:50.545" v="147" actId="478"/>
+      <pc:docMkLst>
+        <pc:docMk/>
+      </pc:docMkLst>
+      <pc:sldChg chg="addSp delSp modSp mod">
+        <pc:chgData name="mio sasaki" userId="4a654686f18dab2c" providerId="LiveId" clId="{14D7E5BE-DE1B-417A-B5B0-45924947C239}" dt="2025-01-30T05:50:33.023" v="144" actId="20577"/>
+        <pc:sldMkLst>
+          <pc:docMk/>
+          <pc:sldMk cId="1214638267" sldId="257"/>
+        </pc:sldMkLst>
+        <pc:spChg chg="add mod">
+          <ac:chgData name="mio sasaki" userId="4a654686f18dab2c" providerId="LiveId" clId="{14D7E5BE-DE1B-417A-B5B0-45924947C239}" dt="2025-01-30T05:46:04.804" v="67" actId="1076"/>
+          <ac:spMkLst>
+            <pc:docMk/>
+            <pc:sldMk cId="1214638267" sldId="257"/>
+            <ac:spMk id="2" creationId="{01AD9725-C410-5FE6-1D41-F0FBB623394B}"/>
+          </ac:spMkLst>
+        </pc:spChg>
+        <pc:spChg chg="add mod">
+          <ac:chgData name="mio sasaki" userId="4a654686f18dab2c" providerId="LiveId" clId="{14D7E5BE-DE1B-417A-B5B0-45924947C239}" dt="2025-01-30T05:49:28.082" v="89" actId="1076"/>
+          <ac:spMkLst>
+            <pc:docMk/>
+            <pc:sldMk cId="1214638267" sldId="257"/>
+            <ac:spMk id="3" creationId="{8B85C44B-8123-EB1C-1279-9B38087DFD05}"/>
+          </ac:spMkLst>
+        </pc:spChg>
+        <pc:spChg chg="mod">
+          <ac:chgData name="mio sasaki" userId="4a654686f18dab2c" providerId="LiveId" clId="{14D7E5BE-DE1B-417A-B5B0-45924947C239}" dt="2025-01-30T05:44:10.905" v="53" actId="1076"/>
+          <ac:spMkLst>
+            <pc:docMk/>
+            <pc:sldMk cId="1214638267" sldId="257"/>
+            <ac:spMk id="4" creationId="{5896890C-E001-5147-5C52-7E9F3F1BB833}"/>
+          </ac:spMkLst>
+        </pc:spChg>
+        <pc:spChg chg="mod">
+          <ac:chgData name="mio sasaki" userId="4a654686f18dab2c" providerId="LiveId" clId="{14D7E5BE-DE1B-417A-B5B0-45924947C239}" dt="2025-01-30T05:44:10.905" v="53" actId="1076"/>
+          <ac:spMkLst>
+            <pc:docMk/>
+            <pc:sldMk cId="1214638267" sldId="257"/>
+            <ac:spMk id="5" creationId="{B2D29D8F-3F9A-370F-FF2D-F87A3F757CBF}"/>
+          </ac:spMkLst>
+        </pc:spChg>
+        <pc:spChg chg="mod">
+          <ac:chgData name="mio sasaki" userId="4a654686f18dab2c" providerId="LiveId" clId="{14D7E5BE-DE1B-417A-B5B0-45924947C239}" dt="2025-01-30T05:50:33.023" v="144" actId="20577"/>
+          <ac:spMkLst>
+            <pc:docMk/>
+            <pc:sldMk cId="1214638267" sldId="257"/>
+            <ac:spMk id="6" creationId="{B4829A55-45DF-E4BD-46A6-51F8BDFF2BD0}"/>
+          </ac:spMkLst>
+        </pc:spChg>
+        <pc:spChg chg="add mod">
+          <ac:chgData name="mio sasaki" userId="4a654686f18dab2c" providerId="LiveId" clId="{14D7E5BE-DE1B-417A-B5B0-45924947C239}" dt="2025-01-30T05:49:28.082" v="89" actId="1076"/>
+          <ac:spMkLst>
+            <pc:docMk/>
+            <pc:sldMk cId="1214638267" sldId="257"/>
+            <ac:spMk id="9" creationId="{EB8F6715-A06A-00BD-0B94-53BA26917703}"/>
+          </ac:spMkLst>
+        </pc:spChg>
+        <pc:spChg chg="mod">
+          <ac:chgData name="mio sasaki" userId="4a654686f18dab2c" providerId="LiveId" clId="{14D7E5BE-DE1B-417A-B5B0-45924947C239}" dt="2025-01-30T05:44:10.905" v="53" actId="1076"/>
+          <ac:spMkLst>
+            <pc:docMk/>
+            <pc:sldMk cId="1214638267" sldId="257"/>
+            <ac:spMk id="10" creationId="{80062F60-1B0B-9E7C-9B92-95FF813A8C83}"/>
+          </ac:spMkLst>
+        </pc:spChg>
+        <pc:spChg chg="mod">
+          <ac:chgData name="mio sasaki" userId="4a654686f18dab2c" providerId="LiveId" clId="{14D7E5BE-DE1B-417A-B5B0-45924947C239}" dt="2025-01-30T05:46:04.804" v="67" actId="1076"/>
+          <ac:spMkLst>
+            <pc:docMk/>
+            <pc:sldMk cId="1214638267" sldId="257"/>
+            <ac:spMk id="11" creationId="{92BDEE35-100E-D40F-B8E0-A64CE619D11C}"/>
+          </ac:spMkLst>
+        </pc:spChg>
+        <pc:spChg chg="mod">
+          <ac:chgData name="mio sasaki" userId="4a654686f18dab2c" providerId="LiveId" clId="{14D7E5BE-DE1B-417A-B5B0-45924947C239}" dt="2025-01-30T05:46:04.804" v="67" actId="1076"/>
+          <ac:spMkLst>
+            <pc:docMk/>
+            <pc:sldMk cId="1214638267" sldId="257"/>
+            <ac:spMk id="12" creationId="{BB311609-2DFB-E7CA-4D5C-B288AD66F6B1}"/>
+          </ac:spMkLst>
+        </pc:spChg>
+        <pc:spChg chg="mod">
+          <ac:chgData name="mio sasaki" userId="4a654686f18dab2c" providerId="LiveId" clId="{14D7E5BE-DE1B-417A-B5B0-45924947C239}" dt="2025-01-30T05:46:04.804" v="67" actId="1076"/>
+          <ac:spMkLst>
+            <pc:docMk/>
+            <pc:sldMk cId="1214638267" sldId="257"/>
+            <ac:spMk id="13" creationId="{C655953E-4172-343E-BBE1-D93CB9EF9052}"/>
+          </ac:spMkLst>
+        </pc:spChg>
+        <pc:spChg chg="mod">
+          <ac:chgData name="mio sasaki" userId="4a654686f18dab2c" providerId="LiveId" clId="{14D7E5BE-DE1B-417A-B5B0-45924947C239}" dt="2025-01-30T05:50:26.680" v="137" actId="14100"/>
+          <ac:spMkLst>
+            <pc:docMk/>
+            <pc:sldMk cId="1214638267" sldId="257"/>
+            <ac:spMk id="14" creationId="{DBBBD15F-C6EB-C7D9-1B3A-D43A6C78E284}"/>
+          </ac:spMkLst>
+        </pc:spChg>
+        <pc:spChg chg="add mod">
+          <ac:chgData name="mio sasaki" userId="4a654686f18dab2c" providerId="LiveId" clId="{14D7E5BE-DE1B-417A-B5B0-45924947C239}" dt="2025-01-30T05:49:28.082" v="89" actId="1076"/>
+          <ac:spMkLst>
+            <pc:docMk/>
+            <pc:sldMk cId="1214638267" sldId="257"/>
+            <ac:spMk id="15" creationId="{3519F1DD-2FC8-B95C-05E8-DD9C92EBFB22}"/>
+          </ac:spMkLst>
+        </pc:spChg>
+        <pc:spChg chg="add mod">
+          <ac:chgData name="mio sasaki" userId="4a654686f18dab2c" providerId="LiveId" clId="{14D7E5BE-DE1B-417A-B5B0-45924947C239}" dt="2025-01-30T05:49:44.207" v="95" actId="20577"/>
+          <ac:spMkLst>
+            <pc:docMk/>
+            <pc:sldMk cId="1214638267" sldId="257"/>
+            <ac:spMk id="16" creationId="{EE202427-8B91-4C62-9B86-95DA84DB3CC2}"/>
+          </ac:spMkLst>
+        </pc:spChg>
+        <pc:spChg chg="del">
+          <ac:chgData name="mio sasaki" userId="4a654686f18dab2c" providerId="LiveId" clId="{14D7E5BE-DE1B-417A-B5B0-45924947C239}" dt="2025-01-30T05:44:20.897" v="54" actId="478"/>
+          <ac:spMkLst>
+            <pc:docMk/>
+            <pc:sldMk cId="1214638267" sldId="257"/>
+            <ac:spMk id="17" creationId="{5BFB447D-009D-3A90-06A2-268875BF87AB}"/>
+          </ac:spMkLst>
+        </pc:spChg>
+        <pc:spChg chg="mod">
+          <ac:chgData name="mio sasaki" userId="4a654686f18dab2c" providerId="LiveId" clId="{14D7E5BE-DE1B-417A-B5B0-45924947C239}" dt="2025-01-30T05:45:56.411" v="66" actId="1076"/>
+          <ac:spMkLst>
+            <pc:docMk/>
+            <pc:sldMk cId="1214638267" sldId="257"/>
+            <ac:spMk id="18" creationId="{453A8B66-DDAE-BB7B-21AC-4AC4FD6E7B6A}"/>
+          </ac:spMkLst>
+        </pc:spChg>
+        <pc:spChg chg="add mod">
+          <ac:chgData name="mio sasaki" userId="4a654686f18dab2c" providerId="LiveId" clId="{14D7E5BE-DE1B-417A-B5B0-45924947C239}" dt="2025-01-30T05:49:47.695" v="99" actId="20577"/>
+          <ac:spMkLst>
+            <pc:docMk/>
+            <pc:sldMk cId="1214638267" sldId="257"/>
+            <ac:spMk id="19" creationId="{F086921C-D5CD-2ACC-9B43-96798D8D272B}"/>
+          </ac:spMkLst>
+        </pc:spChg>
+        <pc:spChg chg="mod">
+          <ac:chgData name="mio sasaki" userId="4a654686f18dab2c" providerId="LiveId" clId="{14D7E5BE-DE1B-417A-B5B0-45924947C239}" dt="2025-01-30T05:45:43.369" v="64" actId="1076"/>
+          <ac:spMkLst>
+            <pc:docMk/>
+            <pc:sldMk cId="1214638267" sldId="257"/>
+            <ac:spMk id="20" creationId="{813A4CC7-4594-FAF5-4A12-582324990789}"/>
+          </ac:spMkLst>
+        </pc:spChg>
+        <pc:spChg chg="mod">
+          <ac:chgData name="mio sasaki" userId="4a654686f18dab2c" providerId="LiveId" clId="{14D7E5BE-DE1B-417A-B5B0-45924947C239}" dt="2025-01-30T05:45:43.369" v="64" actId="1076"/>
+          <ac:spMkLst>
+            <pc:docMk/>
+            <pc:sldMk cId="1214638267" sldId="257"/>
+            <ac:spMk id="21" creationId="{BAA086EE-98CF-6AF2-D73D-9AD185824B73}"/>
+          </ac:spMkLst>
+        </pc:spChg>
+        <pc:spChg chg="mod">
+          <ac:chgData name="mio sasaki" userId="4a654686f18dab2c" providerId="LiveId" clId="{14D7E5BE-DE1B-417A-B5B0-45924947C239}" dt="2025-01-30T05:45:43.369" v="64" actId="1076"/>
+          <ac:spMkLst>
+            <pc:docMk/>
+            <pc:sldMk cId="1214638267" sldId="257"/>
+            <ac:spMk id="22" creationId="{B22C22D0-FB02-703F-B061-AF12F96C1F5C}"/>
+          </ac:spMkLst>
+        </pc:spChg>
+        <pc:spChg chg="add mod">
+          <ac:chgData name="mio sasaki" userId="4a654686f18dab2c" providerId="LiveId" clId="{14D7E5BE-DE1B-417A-B5B0-45924947C239}" dt="2025-01-30T05:49:37.149" v="91" actId="1076"/>
+          <ac:spMkLst>
+            <pc:docMk/>
+            <pc:sldMk cId="1214638267" sldId="257"/>
+            <ac:spMk id="23" creationId="{A72B6B4B-86DA-0E13-65DD-CC202168F897}"/>
+          </ac:spMkLst>
+        </pc:spChg>
+      </pc:sldChg>
+      <pc:sldChg chg="delSp new mod">
+        <pc:chgData name="mio sasaki" userId="4a654686f18dab2c" providerId="LiveId" clId="{14D7E5BE-DE1B-417A-B5B0-45924947C239}" dt="2025-01-30T18:04:50.545" v="147" actId="478"/>
+        <pc:sldMkLst>
+          <pc:docMk/>
+          <pc:sldMk cId="331711909" sldId="258"/>
+        </pc:sldMkLst>
+        <pc:spChg chg="del">
+          <ac:chgData name="mio sasaki" userId="4a654686f18dab2c" providerId="LiveId" clId="{14D7E5BE-DE1B-417A-B5B0-45924947C239}" dt="2025-01-30T18:04:46.805" v="146" actId="478"/>
+          <ac:spMkLst>
+            <pc:docMk/>
+            <pc:sldMk cId="331711909" sldId="258"/>
+            <ac:spMk id="2" creationId="{749A091C-80D0-78AA-88E5-2D94847FC051}"/>
+          </ac:spMkLst>
+        </pc:spChg>
+        <pc:spChg chg="del">
+          <ac:chgData name="mio sasaki" userId="4a654686f18dab2c" providerId="LiveId" clId="{14D7E5BE-DE1B-417A-B5B0-45924947C239}" dt="2025-01-30T18:04:50.545" v="147" actId="478"/>
+          <ac:spMkLst>
+            <pc:docMk/>
+            <pc:sldMk cId="331711909" sldId="258"/>
+            <ac:spMk id="3" creationId="{37E4F3AD-7739-340C-3F75-1628CBEAFF9B}"/>
+          </ac:spMkLst>
+        </pc:spChg>
+      </pc:sldChg>
+    </pc:docChg>
+  </pc:docChgLst>
+</pc:chgInfo>
 </file>
 
 <file path=ppt/slideLayouts/slideLayout1.xml><?xml version="1.0" encoding="utf-8"?>
@@ -254,7 +472,7 @@
           <a:p>
             <a:fld id="{2524DFA6-3E1C-447A-9FDB-AE240EF22FDB}" type="datetimeFigureOut">
               <a:rPr kumimoji="1" lang="ja-JP" altLang="en-US" smtClean="0"/>
-              <a:t>2025/1/27</a:t>
+              <a:t>2025/1/30</a:t>
             </a:fld>
             <a:endParaRPr kumimoji="1" lang="ja-JP" altLang="en-US"/>
           </a:p>
@@ -484,7 +702,7 @@
           <a:p>
             <a:fld id="{2524DFA6-3E1C-447A-9FDB-AE240EF22FDB}" type="datetimeFigureOut">
               <a:rPr kumimoji="1" lang="ja-JP" altLang="en-US" smtClean="0"/>
-              <a:t>2025/1/27</a:t>
+              <a:t>2025/1/30</a:t>
             </a:fld>
             <a:endParaRPr kumimoji="1" lang="ja-JP" altLang="en-US"/>
           </a:p>
@@ -724,7 +942,7 @@
           <a:p>
             <a:fld id="{2524DFA6-3E1C-447A-9FDB-AE240EF22FDB}" type="datetimeFigureOut">
               <a:rPr kumimoji="1" lang="ja-JP" altLang="en-US" smtClean="0"/>
-              <a:t>2025/1/27</a:t>
+              <a:t>2025/1/30</a:t>
             </a:fld>
             <a:endParaRPr kumimoji="1" lang="ja-JP" altLang="en-US"/>
           </a:p>
@@ -954,7 +1172,7 @@
           <a:p>
             <a:fld id="{2524DFA6-3E1C-447A-9FDB-AE240EF22FDB}" type="datetimeFigureOut">
               <a:rPr kumimoji="1" lang="ja-JP" altLang="en-US" smtClean="0"/>
-              <a:t>2025/1/27</a:t>
+              <a:t>2025/1/30</a:t>
             </a:fld>
             <a:endParaRPr kumimoji="1" lang="ja-JP" altLang="en-US"/>
           </a:p>
@@ -1229,7 +1447,7 @@
           <a:p>
             <a:fld id="{2524DFA6-3E1C-447A-9FDB-AE240EF22FDB}" type="datetimeFigureOut">
               <a:rPr kumimoji="1" lang="ja-JP" altLang="en-US" smtClean="0"/>
-              <a:t>2025/1/27</a:t>
+              <a:t>2025/1/30</a:t>
             </a:fld>
             <a:endParaRPr kumimoji="1" lang="ja-JP" altLang="en-US"/>
           </a:p>
@@ -1558,7 +1776,7 @@
           <a:p>
             <a:fld id="{2524DFA6-3E1C-447A-9FDB-AE240EF22FDB}" type="datetimeFigureOut">
               <a:rPr kumimoji="1" lang="ja-JP" altLang="en-US" smtClean="0"/>
-              <a:t>2025/1/27</a:t>
+              <a:t>2025/1/30</a:t>
             </a:fld>
             <a:endParaRPr kumimoji="1" lang="ja-JP" altLang="en-US"/>
           </a:p>
@@ -2034,7 +2252,7 @@
           <a:p>
             <a:fld id="{2524DFA6-3E1C-447A-9FDB-AE240EF22FDB}" type="datetimeFigureOut">
               <a:rPr kumimoji="1" lang="ja-JP" altLang="en-US" smtClean="0"/>
-              <a:t>2025/1/27</a:t>
+              <a:t>2025/1/30</a:t>
             </a:fld>
             <a:endParaRPr kumimoji="1" lang="ja-JP" altLang="en-US"/>
           </a:p>
@@ -2175,7 +2393,7 @@
           <a:p>
             <a:fld id="{2524DFA6-3E1C-447A-9FDB-AE240EF22FDB}" type="datetimeFigureOut">
               <a:rPr kumimoji="1" lang="ja-JP" altLang="en-US" smtClean="0"/>
-              <a:t>2025/1/27</a:t>
+              <a:t>2025/1/30</a:t>
             </a:fld>
             <a:endParaRPr kumimoji="1" lang="ja-JP" altLang="en-US"/>
           </a:p>
@@ -2288,7 +2506,7 @@
           <a:p>
             <a:fld id="{2524DFA6-3E1C-447A-9FDB-AE240EF22FDB}" type="datetimeFigureOut">
               <a:rPr kumimoji="1" lang="ja-JP" altLang="en-US" smtClean="0"/>
-              <a:t>2025/1/27</a:t>
+              <a:t>2025/1/30</a:t>
             </a:fld>
             <a:endParaRPr kumimoji="1" lang="ja-JP" altLang="en-US"/>
           </a:p>
@@ -2631,7 +2849,7 @@
           <a:p>
             <a:fld id="{2524DFA6-3E1C-447A-9FDB-AE240EF22FDB}" type="datetimeFigureOut">
               <a:rPr kumimoji="1" lang="ja-JP" altLang="en-US" smtClean="0"/>
-              <a:t>2025/1/27</a:t>
+              <a:t>2025/1/30</a:t>
             </a:fld>
             <a:endParaRPr kumimoji="1" lang="ja-JP" altLang="en-US"/>
           </a:p>
@@ -2919,7 +3137,7 @@
           <a:p>
             <a:fld id="{2524DFA6-3E1C-447A-9FDB-AE240EF22FDB}" type="datetimeFigureOut">
               <a:rPr kumimoji="1" lang="ja-JP" altLang="en-US" smtClean="0"/>
-              <a:t>2025/1/27</a:t>
+              <a:t>2025/1/30</a:t>
             </a:fld>
             <a:endParaRPr kumimoji="1" lang="ja-JP" altLang="en-US"/>
           </a:p>
@@ -3192,7 +3410,7 @@
           <a:p>
             <a:fld id="{2524DFA6-3E1C-447A-9FDB-AE240EF22FDB}" type="datetimeFigureOut">
               <a:rPr kumimoji="1" lang="ja-JP" altLang="en-US" smtClean="0"/>
-              <a:t>2025/1/27</a:t>
+              <a:t>2025/1/30</a:t>
             </a:fld>
             <a:endParaRPr kumimoji="1" lang="ja-JP" altLang="en-US"/>
           </a:p>
@@ -3717,7 +3935,7 @@
         </p:nvSpPr>
         <p:spPr>
           <a:xfrm rot="19824443">
-            <a:off x="1125171" y="2406480"/>
+            <a:off x="2869995" y="2438795"/>
             <a:ext cx="401023" cy="213167"/>
           </a:xfrm>
           <a:prstGeom prst="ellipse">
@@ -3763,7 +3981,7 @@
         </p:nvSpPr>
         <p:spPr>
           <a:xfrm>
-            <a:off x="1458779" y="1672011"/>
+            <a:off x="3203603" y="1704326"/>
             <a:ext cx="45719" cy="781912"/>
           </a:xfrm>
           <a:prstGeom prst="rect">
@@ -3809,8 +4027,8 @@
         </p:nvSpPr>
         <p:spPr>
           <a:xfrm>
-            <a:off x="668824" y="545341"/>
-            <a:ext cx="4949656" cy="523220"/>
+            <a:off x="668823" y="545341"/>
+            <a:ext cx="9390509" cy="523220"/>
           </a:xfrm>
           <a:prstGeom prst="rect">
             <a:avLst/>
@@ -3828,8 +4046,40 @@
                 <a:latin typeface="ＭＳ ゴシック" panose="020B0609070205080204" pitchFamily="49" charset="-128"/>
                 <a:ea typeface="ＭＳ ゴシック" panose="020B0609070205080204" pitchFamily="49" charset="-128"/>
               </a:rPr>
-              <a:t>四分音符が基準の場合</a:t>
-            </a:r>
+              <a:t>四分音符が基準の場合（例：</a:t>
+            </a:r>
+            <a:r>
+              <a:rPr kumimoji="1" lang="en-US" altLang="ja-JP" sz="2800" dirty="0">
+                <a:latin typeface="ＭＳ ゴシック" panose="020B0609070205080204" pitchFamily="49" charset="-128"/>
+                <a:ea typeface="ＭＳ ゴシック" panose="020B0609070205080204" pitchFamily="49" charset="-128"/>
+              </a:rPr>
+              <a:t>4</a:t>
+            </a:r>
+            <a:r>
+              <a:rPr kumimoji="1" lang="ja-JP" altLang="en-US" sz="2800" dirty="0">
+                <a:latin typeface="ＭＳ ゴシック" panose="020B0609070205080204" pitchFamily="49" charset="-128"/>
+                <a:ea typeface="ＭＳ ゴシック" panose="020B0609070205080204" pitchFamily="49" charset="-128"/>
+              </a:rPr>
+              <a:t>分の</a:t>
+            </a:r>
+            <a:r>
+              <a:rPr kumimoji="1" lang="en-US" altLang="ja-JP" sz="2800" dirty="0">
+                <a:latin typeface="ＭＳ ゴシック" panose="020B0609070205080204" pitchFamily="49" charset="-128"/>
+                <a:ea typeface="ＭＳ ゴシック" panose="020B0609070205080204" pitchFamily="49" charset="-128"/>
+              </a:rPr>
+              <a:t>4</a:t>
+            </a:r>
+            <a:r>
+              <a:rPr kumimoji="1" lang="ja-JP" altLang="en-US" sz="2800">
+                <a:latin typeface="ＭＳ ゴシック" panose="020B0609070205080204" pitchFamily="49" charset="-128"/>
+                <a:ea typeface="ＭＳ ゴシック" panose="020B0609070205080204" pitchFamily="49" charset="-128"/>
+              </a:rPr>
+              <a:t>拍子）</a:t>
+            </a:r>
+            <a:endParaRPr kumimoji="1" lang="ja-JP" altLang="en-US" sz="2800" dirty="0">
+              <a:latin typeface="ＭＳ ゴシック" panose="020B0609070205080204" pitchFamily="49" charset="-128"/>
+              <a:ea typeface="ＭＳ ゴシック" panose="020B0609070205080204" pitchFamily="49" charset="-128"/>
+            </a:endParaRPr>
           </a:p>
         </p:txBody>
       </p:sp>
@@ -3847,7 +4097,7 @@
         </p:nvSpPr>
         <p:spPr>
           <a:xfrm>
-            <a:off x="1810270" y="1929461"/>
+            <a:off x="3555094" y="1961776"/>
             <a:ext cx="1567411" cy="523220"/>
           </a:xfrm>
           <a:prstGeom prst="rect">
@@ -3896,7 +4146,7 @@
         </p:nvSpPr>
         <p:spPr>
           <a:xfrm rot="19824443">
-            <a:off x="1074371" y="5627200"/>
+            <a:off x="2649563" y="5651823"/>
             <a:ext cx="401023" cy="213167"/>
           </a:xfrm>
           <a:prstGeom prst="ellipse">
@@ -3942,7 +4192,7 @@
         </p:nvSpPr>
         <p:spPr>
           <a:xfrm>
-            <a:off x="1413060" y="4866572"/>
+            <a:off x="2988252" y="4891195"/>
             <a:ext cx="45719" cy="781912"/>
           </a:xfrm>
           <a:prstGeom prst="rect">
@@ -3988,7 +4238,7 @@
         </p:nvSpPr>
         <p:spPr>
           <a:xfrm>
-            <a:off x="1759470" y="5150181"/>
+            <a:off x="3334662" y="5174804"/>
             <a:ext cx="1567411" cy="523220"/>
           </a:xfrm>
           <a:prstGeom prst="rect">
@@ -4014,7 +4264,7 @@
                 <a:latin typeface="ＭＳ ゴシック" panose="020B0609070205080204" pitchFamily="49" charset="-128"/>
                 <a:ea typeface="ＭＳ ゴシック" panose="020B0609070205080204" pitchFamily="49" charset="-128"/>
               </a:rPr>
-              <a:t>180</a:t>
+              <a:t>45</a:t>
             </a:r>
             <a:endParaRPr kumimoji="1" lang="ja-JP" altLang="en-US" sz="2800" dirty="0">
               <a:latin typeface="ＭＳ ゴシック" panose="020B0609070205080204" pitchFamily="49" charset="-128"/>
@@ -4038,7 +4288,7 @@
         <p:spPr>
           <a:xfrm>
             <a:off x="668824" y="3815825"/>
-            <a:ext cx="7388056" cy="523220"/>
+            <a:ext cx="8576776" cy="523220"/>
           </a:xfrm>
           <a:prstGeom prst="rect">
             <a:avLst/>
@@ -4056,7 +4306,35 @@
                 <a:latin typeface="ＭＳ ゴシック" panose="020B0609070205080204" pitchFamily="49" charset="-128"/>
                 <a:ea typeface="ＭＳ ゴシック" panose="020B0609070205080204" pitchFamily="49" charset="-128"/>
               </a:rPr>
-              <a:t>その他の音符が基準の場合（例：八分音符）</a:t>
+              <a:t>その他の音符が基準の場合（例：</a:t>
+            </a:r>
+            <a:r>
+              <a:rPr lang="en-US" altLang="ja-JP" sz="2800" dirty="0">
+                <a:latin typeface="ＭＳ ゴシック" panose="020B0609070205080204" pitchFamily="49" charset="-128"/>
+                <a:ea typeface="ＭＳ ゴシック" panose="020B0609070205080204" pitchFamily="49" charset="-128"/>
+              </a:rPr>
+              <a:t>8</a:t>
+            </a:r>
+            <a:r>
+              <a:rPr lang="ja-JP" altLang="en-US" sz="2800" dirty="0">
+                <a:latin typeface="ＭＳ ゴシック" panose="020B0609070205080204" pitchFamily="49" charset="-128"/>
+                <a:ea typeface="ＭＳ ゴシック" panose="020B0609070205080204" pitchFamily="49" charset="-128"/>
+              </a:rPr>
+              <a:t>分の</a:t>
+            </a:r>
+            <a:r>
+              <a:rPr lang="en-US" altLang="ja-JP" sz="2800" dirty="0">
+                <a:latin typeface="ＭＳ ゴシック" panose="020B0609070205080204" pitchFamily="49" charset="-128"/>
+                <a:ea typeface="ＭＳ ゴシック" panose="020B0609070205080204" pitchFamily="49" charset="-128"/>
+              </a:rPr>
+              <a:t>6</a:t>
+            </a:r>
+            <a:r>
+              <a:rPr lang="ja-JP" altLang="en-US" sz="2800" dirty="0">
+                <a:latin typeface="ＭＳ ゴシック" panose="020B0609070205080204" pitchFamily="49" charset="-128"/>
+                <a:ea typeface="ＭＳ ゴシック" panose="020B0609070205080204" pitchFamily="49" charset="-128"/>
+              </a:rPr>
+              <a:t>拍子）</a:t>
             </a:r>
             <a:endParaRPr kumimoji="1" lang="ja-JP" altLang="en-US" sz="2800" dirty="0">
               <a:latin typeface="ＭＳ ゴシック" panose="020B0609070205080204" pitchFamily="49" charset="-128"/>
@@ -4067,10 +4345,10 @@
       </p:sp>
       <p:sp>
         <p:nvSpPr>
-          <p:cNvPr id="17" name="フリーフォーム: 図形 16">
-            <a:extLst>
-              <a:ext uri="{FF2B5EF4-FFF2-40B4-BE49-F238E27FC236}">
-                <a16:creationId xmlns:a16="http://schemas.microsoft.com/office/drawing/2014/main" id="{5BFB447D-009D-3A90-06A2-268875BF87AB}"/>
+          <p:cNvPr id="18" name="矢印: 右 17">
+            <a:extLst>
+              <a:ext uri="{FF2B5EF4-FFF2-40B4-BE49-F238E27FC236}">
+                <a16:creationId xmlns:a16="http://schemas.microsoft.com/office/drawing/2014/main" id="{453A8B66-DDAE-BB7B-21AC-4AC4FD6E7B6A}"/>
               </a:ext>
             </a:extLst>
           </p:cNvPr>
@@ -4078,137 +4356,14 @@
           <p:nvPr/>
         </p:nvSpPr>
         <p:spPr>
-          <a:xfrm rot="19107636" flipH="1">
-            <a:off x="1379982" y="4842988"/>
-            <a:ext cx="296199" cy="516746"/>
-          </a:xfrm>
-          <a:custGeom>
-            <a:avLst/>
-            <a:gdLst>
-              <a:gd name="connsiteX0" fmla="*/ 57897 w 296199"/>
-              <a:gd name="connsiteY0" fmla="*/ 0 h 516746"/>
-              <a:gd name="connsiteX1" fmla="*/ 50586 w 296199"/>
-              <a:gd name="connsiteY1" fmla="*/ 9728 h 516746"/>
-              <a:gd name="connsiteX2" fmla="*/ 0 w 296199"/>
-              <a:gd name="connsiteY2" fmla="*/ 191549 h 516746"/>
-              <a:gd name="connsiteX3" fmla="*/ 296199 w 296199"/>
-              <a:gd name="connsiteY3" fmla="*/ 516746 h 516746"/>
-              <a:gd name="connsiteX4" fmla="*/ 118930 w 296199"/>
-              <a:gd name="connsiteY4" fmla="*/ 191549 h 516746"/>
-              <a:gd name="connsiteX5" fmla="*/ 131279 w 296199"/>
-              <a:gd name="connsiteY5" fmla="*/ 92407 h 516746"/>
-              <a:gd name="connsiteX6" fmla="*/ 133879 w 296199"/>
-              <a:gd name="connsiteY6" fmla="*/ 85762 h 516746"/>
-            </a:gdLst>
-            <a:ahLst/>
-            <a:cxnLst>
-              <a:cxn ang="0">
-                <a:pos x="connsiteX0" y="connsiteY0"/>
-              </a:cxn>
-              <a:cxn ang="0">
-                <a:pos x="connsiteX1" y="connsiteY1"/>
-              </a:cxn>
-              <a:cxn ang="0">
-                <a:pos x="connsiteX2" y="connsiteY2"/>
-              </a:cxn>
-              <a:cxn ang="0">
-                <a:pos x="connsiteX3" y="connsiteY3"/>
-              </a:cxn>
-              <a:cxn ang="0">
-                <a:pos x="connsiteX4" y="connsiteY4"/>
-              </a:cxn>
-              <a:cxn ang="0">
-                <a:pos x="connsiteX5" y="connsiteY5"/>
-              </a:cxn>
-              <a:cxn ang="0">
-                <a:pos x="connsiteX6" y="connsiteY6"/>
-              </a:cxn>
-            </a:cxnLst>
-            <a:rect l="l" t="t" r="r" b="b"/>
-            <a:pathLst>
-              <a:path w="296199" h="516746">
-                <a:moveTo>
-                  <a:pt x="57897" y="0"/>
-                </a:moveTo>
-                <a:lnTo>
-                  <a:pt x="50586" y="9728"/>
-                </a:lnTo>
-                <a:cubicBezTo>
-                  <a:pt x="18649" y="61630"/>
-                  <a:pt x="0" y="124198"/>
-                  <a:pt x="0" y="191549"/>
-                </a:cubicBezTo>
-                <a:cubicBezTo>
-                  <a:pt x="0" y="371150"/>
-                  <a:pt x="132613" y="516746"/>
-                  <a:pt x="296199" y="516746"/>
-                </a:cubicBezTo>
-                <a:cubicBezTo>
-                  <a:pt x="187047" y="452488"/>
-                  <a:pt x="118930" y="327528"/>
-                  <a:pt x="118930" y="191549"/>
-                </a:cubicBezTo>
-                <a:cubicBezTo>
-                  <a:pt x="118930" y="157554"/>
-                  <a:pt x="123187" y="124248"/>
-                  <a:pt x="131279" y="92407"/>
-                </a:cubicBezTo>
-                <a:lnTo>
-                  <a:pt x="133879" y="85762"/>
-                </a:lnTo>
-                <a:close/>
-              </a:path>
-            </a:pathLst>
-          </a:custGeom>
-        </p:spPr>
-        <p:style>
-          <a:lnRef idx="2">
-            <a:schemeClr val="dk1">
-              <a:shade val="15000"/>
-            </a:schemeClr>
-          </a:lnRef>
-          <a:fillRef idx="1">
-            <a:schemeClr val="dk1"/>
-          </a:fillRef>
-          <a:effectRef idx="0">
-            <a:schemeClr val="dk1"/>
-          </a:effectRef>
-          <a:fontRef idx="minor">
-            <a:schemeClr val="lt1"/>
-          </a:fontRef>
-        </p:style>
-        <p:txBody>
-          <a:bodyPr wrap="square" rtlCol="0" anchor="ctr">
-            <a:noAutofit/>
-          </a:bodyPr>
-          <a:lstStyle/>
-          <a:p>
-            <a:pPr algn="ctr"/>
-            <a:endParaRPr kumimoji="1" lang="ja-JP" altLang="en-US"/>
-          </a:p>
-        </p:txBody>
-      </p:sp>
-      <p:sp>
-        <p:nvSpPr>
-          <p:cNvPr id="18" name="矢印: 右 17">
-            <a:extLst>
-              <a:ext uri="{FF2B5EF4-FFF2-40B4-BE49-F238E27FC236}">
-                <a16:creationId xmlns:a16="http://schemas.microsoft.com/office/drawing/2014/main" id="{453A8B66-DDAE-BB7B-21AC-4AC4FD6E7B6A}"/>
-              </a:ext>
-            </a:extLst>
-          </p:cNvPr>
-          <p:cNvSpPr/>
-          <p:nvPr/>
-        </p:nvSpPr>
-        <p:spPr>
           <a:xfrm>
-            <a:off x="4000480" y="4817058"/>
-            <a:ext cx="4030610" cy="1189465"/>
+            <a:off x="5493124" y="4811992"/>
+            <a:ext cx="3024750" cy="1189465"/>
           </a:xfrm>
           <a:prstGeom prst="rightArrow">
             <a:avLst>
               <a:gd name="adj1" fmla="val 50000"/>
-              <a:gd name="adj2" fmla="val 104371"/>
+              <a:gd name="adj2" fmla="val 80668"/>
             </a:avLst>
           </a:prstGeom>
           <a:solidFill>
@@ -4263,7 +4418,7 @@
         </p:nvSpPr>
         <p:spPr>
           <a:xfrm rot="19824443">
-            <a:off x="8521651" y="5636405"/>
+            <a:off x="9014877" y="5633002"/>
             <a:ext cx="401023" cy="213167"/>
           </a:xfrm>
           <a:prstGeom prst="ellipse">
@@ -4309,7 +4464,7 @@
         </p:nvSpPr>
         <p:spPr>
           <a:xfrm>
-            <a:off x="8855259" y="4901936"/>
+            <a:off x="9348485" y="4898533"/>
             <a:ext cx="45719" cy="781912"/>
           </a:xfrm>
           <a:prstGeom prst="rect">
@@ -4355,7 +4510,7 @@
         </p:nvSpPr>
         <p:spPr>
           <a:xfrm>
-            <a:off x="9206750" y="5159386"/>
+            <a:off x="9699976" y="5155983"/>
             <a:ext cx="1567411" cy="523220"/>
           </a:xfrm>
           <a:prstGeom prst="rect">
@@ -4390,10 +4545,355 @@
           </a:p>
         </p:txBody>
       </p:sp>
+      <p:sp>
+        <p:nvSpPr>
+          <p:cNvPr id="2" name="楕円 1">
+            <a:extLst>
+              <a:ext uri="{FF2B5EF4-FFF2-40B4-BE49-F238E27FC236}">
+                <a16:creationId xmlns:a16="http://schemas.microsoft.com/office/drawing/2014/main" id="{01AD9725-C410-5FE6-1D41-F0FBB623394B}"/>
+              </a:ext>
+            </a:extLst>
+          </p:cNvPr>
+          <p:cNvSpPr/>
+          <p:nvPr/>
+        </p:nvSpPr>
+        <p:spPr>
+          <a:xfrm>
+            <a:off x="3115174" y="5758406"/>
+            <a:ext cx="90690" cy="91440"/>
+          </a:xfrm>
+          <a:prstGeom prst="ellipse">
+            <a:avLst/>
+          </a:prstGeom>
+          <a:solidFill>
+            <a:schemeClr val="tx1"/>
+          </a:solidFill>
+        </p:spPr>
+        <p:style>
+          <a:lnRef idx="2">
+            <a:schemeClr val="accent1">
+              <a:shade val="15000"/>
+            </a:schemeClr>
+          </a:lnRef>
+          <a:fillRef idx="1">
+            <a:schemeClr val="accent1"/>
+          </a:fillRef>
+          <a:effectRef idx="0">
+            <a:schemeClr val="accent1"/>
+          </a:effectRef>
+          <a:fontRef idx="minor">
+            <a:schemeClr val="lt1"/>
+          </a:fontRef>
+        </p:style>
+        <p:txBody>
+          <a:bodyPr rtlCol="0" anchor="ctr"/>
+          <a:lstStyle/>
+          <a:p>
+            <a:pPr algn="ctr"/>
+            <a:endParaRPr kumimoji="1" lang="ja-JP" altLang="en-US"/>
+          </a:p>
+        </p:txBody>
+      </p:sp>
+      <p:sp>
+        <p:nvSpPr>
+          <p:cNvPr id="3" name="テキスト ボックス 2">
+            <a:extLst>
+              <a:ext uri="{FF2B5EF4-FFF2-40B4-BE49-F238E27FC236}">
+                <a16:creationId xmlns:a16="http://schemas.microsoft.com/office/drawing/2014/main" id="{8B85C44B-8123-EB1C-1279-9B38087DFD05}"/>
+              </a:ext>
+            </a:extLst>
+          </p:cNvPr>
+          <p:cNvSpPr txBox="1"/>
+          <p:nvPr/>
+        </p:nvSpPr>
+        <p:spPr>
+          <a:xfrm>
+            <a:off x="1336997" y="1196415"/>
+            <a:ext cx="914400" cy="1015663"/>
+          </a:xfrm>
+          <a:prstGeom prst="rect">
+            <a:avLst/>
+          </a:prstGeom>
+          <a:noFill/>
+        </p:spPr>
+        <p:txBody>
+          <a:bodyPr wrap="square" rtlCol="0">
+            <a:spAutoFit/>
+          </a:bodyPr>
+          <a:lstStyle/>
+          <a:p>
+            <a:r>
+              <a:rPr kumimoji="1" lang="en-US" altLang="ja-JP" sz="6000" dirty="0">
+                <a:latin typeface="ＭＳ ゴシック" panose="020B0609070205080204" pitchFamily="49" charset="-128"/>
+                <a:ea typeface="ＭＳ ゴシック" panose="020B0609070205080204" pitchFamily="49" charset="-128"/>
+              </a:rPr>
+              <a:t>4</a:t>
+            </a:r>
+            <a:endParaRPr kumimoji="1" lang="ja-JP" altLang="en-US" sz="6000" dirty="0">
+              <a:latin typeface="ＭＳ ゴシック" panose="020B0609070205080204" pitchFamily="49" charset="-128"/>
+              <a:ea typeface="ＭＳ ゴシック" panose="020B0609070205080204" pitchFamily="49" charset="-128"/>
+            </a:endParaRPr>
+          </a:p>
+        </p:txBody>
+      </p:sp>
+      <p:sp>
+        <p:nvSpPr>
+          <p:cNvPr id="9" name="テキスト ボックス 8">
+            <a:extLst>
+              <a:ext uri="{FF2B5EF4-FFF2-40B4-BE49-F238E27FC236}">
+                <a16:creationId xmlns:a16="http://schemas.microsoft.com/office/drawing/2014/main" id="{EB8F6715-A06A-00BD-0B94-53BA26917703}"/>
+              </a:ext>
+            </a:extLst>
+          </p:cNvPr>
+          <p:cNvSpPr txBox="1"/>
+          <p:nvPr/>
+        </p:nvSpPr>
+        <p:spPr>
+          <a:xfrm>
+            <a:off x="1312909" y="2054297"/>
+            <a:ext cx="914400" cy="1015663"/>
+          </a:xfrm>
+          <a:prstGeom prst="rect">
+            <a:avLst/>
+          </a:prstGeom>
+          <a:noFill/>
+        </p:spPr>
+        <p:txBody>
+          <a:bodyPr wrap="square" rtlCol="0">
+            <a:spAutoFit/>
+          </a:bodyPr>
+          <a:lstStyle/>
+          <a:p>
+            <a:r>
+              <a:rPr kumimoji="1" lang="en-US" altLang="ja-JP" sz="6000" dirty="0">
+                <a:latin typeface="ＭＳ ゴシック" panose="020B0609070205080204" pitchFamily="49" charset="-128"/>
+                <a:ea typeface="ＭＳ ゴシック" panose="020B0609070205080204" pitchFamily="49" charset="-128"/>
+              </a:rPr>
+              <a:t>4</a:t>
+            </a:r>
+            <a:endParaRPr kumimoji="1" lang="ja-JP" altLang="en-US" sz="6000" dirty="0">
+              <a:latin typeface="ＭＳ ゴシック" panose="020B0609070205080204" pitchFamily="49" charset="-128"/>
+              <a:ea typeface="ＭＳ ゴシック" panose="020B0609070205080204" pitchFamily="49" charset="-128"/>
+            </a:endParaRPr>
+          </a:p>
+        </p:txBody>
+      </p:sp>
+      <p:sp>
+        <p:nvSpPr>
+          <p:cNvPr id="15" name="正方形/長方形 14">
+            <a:extLst>
+              <a:ext uri="{FF2B5EF4-FFF2-40B4-BE49-F238E27FC236}">
+                <a16:creationId xmlns:a16="http://schemas.microsoft.com/office/drawing/2014/main" id="{3519F1DD-2FC8-B95C-05E8-DD9C92EBFB22}"/>
+              </a:ext>
+            </a:extLst>
+          </p:cNvPr>
+          <p:cNvSpPr/>
+          <p:nvPr/>
+        </p:nvSpPr>
+        <p:spPr>
+          <a:xfrm>
+            <a:off x="1110279" y="2139396"/>
+            <a:ext cx="1072515" cy="45719"/>
+          </a:xfrm>
+          <a:prstGeom prst="rect">
+            <a:avLst/>
+          </a:prstGeom>
+          <a:solidFill>
+            <a:schemeClr val="tx1"/>
+          </a:solidFill>
+        </p:spPr>
+        <p:style>
+          <a:lnRef idx="2">
+            <a:schemeClr val="accent1">
+              <a:shade val="15000"/>
+            </a:schemeClr>
+          </a:lnRef>
+          <a:fillRef idx="1">
+            <a:schemeClr val="accent1"/>
+          </a:fillRef>
+          <a:effectRef idx="0">
+            <a:schemeClr val="accent1"/>
+          </a:effectRef>
+          <a:fontRef idx="minor">
+            <a:schemeClr val="lt1"/>
+          </a:fontRef>
+        </p:style>
+        <p:txBody>
+          <a:bodyPr rtlCol="0" anchor="ctr"/>
+          <a:lstStyle/>
+          <a:p>
+            <a:pPr algn="ctr"/>
+            <a:endParaRPr kumimoji="1" lang="ja-JP" altLang="en-US"/>
+          </a:p>
+        </p:txBody>
+      </p:sp>
+      <p:sp>
+        <p:nvSpPr>
+          <p:cNvPr id="16" name="テキスト ボックス 15">
+            <a:extLst>
+              <a:ext uri="{FF2B5EF4-FFF2-40B4-BE49-F238E27FC236}">
+                <a16:creationId xmlns:a16="http://schemas.microsoft.com/office/drawing/2014/main" id="{EE202427-8B91-4C62-9B86-95DA84DB3CC2}"/>
+              </a:ext>
+            </a:extLst>
+          </p:cNvPr>
+          <p:cNvSpPr txBox="1"/>
+          <p:nvPr/>
+        </p:nvSpPr>
+        <p:spPr>
+          <a:xfrm>
+            <a:off x="1274063" y="4443679"/>
+            <a:ext cx="914400" cy="1015663"/>
+          </a:xfrm>
+          <a:prstGeom prst="rect">
+            <a:avLst/>
+          </a:prstGeom>
+          <a:noFill/>
+        </p:spPr>
+        <p:txBody>
+          <a:bodyPr wrap="square" rtlCol="0">
+            <a:spAutoFit/>
+          </a:bodyPr>
+          <a:lstStyle/>
+          <a:p>
+            <a:r>
+              <a:rPr lang="en-US" altLang="ja-JP" sz="6000" dirty="0">
+                <a:latin typeface="ＭＳ ゴシック" panose="020B0609070205080204" pitchFamily="49" charset="-128"/>
+                <a:ea typeface="ＭＳ ゴシック" panose="020B0609070205080204" pitchFamily="49" charset="-128"/>
+              </a:rPr>
+              <a:t>6</a:t>
+            </a:r>
+            <a:endParaRPr kumimoji="1" lang="ja-JP" altLang="en-US" sz="6000" dirty="0">
+              <a:latin typeface="ＭＳ ゴシック" panose="020B0609070205080204" pitchFamily="49" charset="-128"/>
+              <a:ea typeface="ＭＳ ゴシック" panose="020B0609070205080204" pitchFamily="49" charset="-128"/>
+            </a:endParaRPr>
+          </a:p>
+        </p:txBody>
+      </p:sp>
+      <p:sp>
+        <p:nvSpPr>
+          <p:cNvPr id="19" name="テキスト ボックス 18">
+            <a:extLst>
+              <a:ext uri="{FF2B5EF4-FFF2-40B4-BE49-F238E27FC236}">
+                <a16:creationId xmlns:a16="http://schemas.microsoft.com/office/drawing/2014/main" id="{F086921C-D5CD-2ACC-9B43-96798D8D272B}"/>
+              </a:ext>
+            </a:extLst>
+          </p:cNvPr>
+          <p:cNvSpPr txBox="1"/>
+          <p:nvPr/>
+        </p:nvSpPr>
+        <p:spPr>
+          <a:xfrm>
+            <a:off x="1249975" y="5301561"/>
+            <a:ext cx="914400" cy="1015663"/>
+          </a:xfrm>
+          <a:prstGeom prst="rect">
+            <a:avLst/>
+          </a:prstGeom>
+          <a:noFill/>
+        </p:spPr>
+        <p:txBody>
+          <a:bodyPr wrap="square" rtlCol="0">
+            <a:spAutoFit/>
+          </a:bodyPr>
+          <a:lstStyle/>
+          <a:p>
+            <a:r>
+              <a:rPr lang="en-US" altLang="ja-JP" sz="6000" dirty="0">
+                <a:latin typeface="ＭＳ ゴシック" panose="020B0609070205080204" pitchFamily="49" charset="-128"/>
+                <a:ea typeface="ＭＳ ゴシック" panose="020B0609070205080204" pitchFamily="49" charset="-128"/>
+              </a:rPr>
+              <a:t>8</a:t>
+            </a:r>
+            <a:endParaRPr kumimoji="1" lang="ja-JP" altLang="en-US" sz="6000" dirty="0">
+              <a:latin typeface="ＭＳ ゴシック" panose="020B0609070205080204" pitchFamily="49" charset="-128"/>
+              <a:ea typeface="ＭＳ ゴシック" panose="020B0609070205080204" pitchFamily="49" charset="-128"/>
+            </a:endParaRPr>
+          </a:p>
+        </p:txBody>
+      </p:sp>
+      <p:sp>
+        <p:nvSpPr>
+          <p:cNvPr id="23" name="正方形/長方形 22">
+            <a:extLst>
+              <a:ext uri="{FF2B5EF4-FFF2-40B4-BE49-F238E27FC236}">
+                <a16:creationId xmlns:a16="http://schemas.microsoft.com/office/drawing/2014/main" id="{A72B6B4B-86DA-0E13-65DD-CC202168F897}"/>
+              </a:ext>
+            </a:extLst>
+          </p:cNvPr>
+          <p:cNvSpPr/>
+          <p:nvPr/>
+        </p:nvSpPr>
+        <p:spPr>
+          <a:xfrm>
+            <a:off x="1047345" y="5386660"/>
+            <a:ext cx="1072515" cy="45719"/>
+          </a:xfrm>
+          <a:prstGeom prst="rect">
+            <a:avLst/>
+          </a:prstGeom>
+          <a:solidFill>
+            <a:schemeClr val="tx1"/>
+          </a:solidFill>
+        </p:spPr>
+        <p:style>
+          <a:lnRef idx="2">
+            <a:schemeClr val="accent1">
+              <a:shade val="15000"/>
+            </a:schemeClr>
+          </a:lnRef>
+          <a:fillRef idx="1">
+            <a:schemeClr val="accent1"/>
+          </a:fillRef>
+          <a:effectRef idx="0">
+            <a:schemeClr val="accent1"/>
+          </a:effectRef>
+          <a:fontRef idx="minor">
+            <a:schemeClr val="lt1"/>
+          </a:fontRef>
+        </p:style>
+        <p:txBody>
+          <a:bodyPr rtlCol="0" anchor="ctr"/>
+          <a:lstStyle/>
+          <a:p>
+            <a:pPr algn="ctr"/>
+            <a:endParaRPr kumimoji="1" lang="ja-JP" altLang="en-US"/>
+          </a:p>
+        </p:txBody>
+      </p:sp>
     </p:spTree>
     <p:extLst>
       <p:ext uri="{BB962C8B-B14F-4D97-AF65-F5344CB8AC3E}">
         <p14:creationId xmlns:p14="http://schemas.microsoft.com/office/powerpoint/2010/main" val="1214638267"/>
+      </p:ext>
+    </p:extLst>
+  </p:cSld>
+  <p:clrMapOvr>
+    <a:masterClrMapping/>
+  </p:clrMapOvr>
+</p:sld>
+</file>
+
+<file path=ppt/slides/slide2.xml><?xml version="1.0" encoding="utf-8"?>
+<p:sld xmlns:a="http://schemas.openxmlformats.org/drawingml/2006/main" xmlns:r="http://schemas.openxmlformats.org/officeDocument/2006/relationships" xmlns:p="http://schemas.openxmlformats.org/presentationml/2006/main">
+  <p:cSld>
+    <p:spTree>
+      <p:nvGrpSpPr>
+        <p:cNvPr id="1" name=""/>
+        <p:cNvGrpSpPr/>
+        <p:nvPr/>
+      </p:nvGrpSpPr>
+      <p:grpSpPr>
+        <a:xfrm>
+          <a:off x="0" y="0"/>
+          <a:ext cx="0" cy="0"/>
+          <a:chOff x="0" y="0"/>
+          <a:chExt cx="0" cy="0"/>
+        </a:xfrm>
+      </p:grpSpPr>
+    </p:spTree>
+    <p:extLst>
+      <p:ext uri="{BB962C8B-B14F-4D97-AF65-F5344CB8AC3E}">
+        <p14:creationId xmlns:p14="http://schemas.microsoft.com/office/powerpoint/2010/main" val="331711909"/>
       </p:ext>
     </p:extLst>
   </p:cSld>

</xml_diff>